<commit_message>
creator credit fixed everywhere: Ayush, Navam, and Sandeep (AI prompt, instant identity answers, tech-stack line, PPT)
</commit_message>
<xml_diff>
--- a/presentation/Syrax-Presentation.pptx
+++ b/presentation/Syrax-Presentation.pptx
@@ -511,7 +511,7 @@
           <a:lstStyle/>
           <a:p>
             <a:r>
-              <a:t>Syrax — a voice agent you talk to like a person. It listens once, acts in real Chrome tabs, and installs as an app on desktop and Android. Presenter: Navam.</a:t>
+              <a:t>Syrax — a voice agent you talk to like a person. It listens once, acts in real Chrome tabs, and installs as an app on desktop and Android. Creators: Ayush, Navam &amp; Sandeep.</a:t>
             </a:r>
           </a:p>
         </p:txBody>
@@ -4526,7 +4526,7 @@
                 </a:solidFill>
                 <a:latin typeface="Calibri"/>
               </a:rPr>
-              <a:t>Created by Navam</a:t>
+              <a:t>Created by Ayush, Navam &amp; Sandeep</a:t>
             </a:r>
           </a:p>
           <a:p>
@@ -5194,7 +5194,7 @@
                 </a:solidFill>
                 <a:latin typeface="Calibri"/>
               </a:rPr>
-              <a:t>Syrax — Mark 1  ·  Created by Navam</a:t>
+              <a:t>Syrax — Mark 1  ·  Created by Ayush, Navam &amp; Sandeep</a:t>
             </a:r>
           </a:p>
         </p:txBody>

</xml_diff>